<commit_message>
Lead every slide's notes with its key point, add the so-what answer
Each note opens with the one thing the audience must understand from that
slide. Slides 1, 11 and 15 carry the so-what answer. Slides 2 and 11
scripts trimmed.
</commit_message>
<xml_diff>
--- a/docs/defence/Monarch_Supervisor_Deck_Script.pptx
+++ b/docs/defence/Monarch_Supervisor_Deck_Script.pptx
@@ -1007,6 +1007,12 @@
           <a:lstStyle/>
           <a:p>
             <a:r>
+              <a:t>KEY POINT: Media's push on opinion is always guessed. This work measures a candidate for it and turns its unknown strength into a minimum any claim must meet.</a:t>
+            </a:r>
+          </a:p>
+          <a:p/>
+          <a:p>
+            <a:r>
               <a:t>SCRIPT (about 1 min)</a:t>
             </a:r>
           </a:p>
@@ -1040,6 +1046,17 @@
           <a:p>
             <a:r>
               <a:t>- Sociophysics: using the tools of statistical physics to model how groups of people behave.</a:t>
+            </a:r>
+          </a:p>
+          <a:p/>
+          <a:p>
+            <a:r>
+              <a:t>IF ASKED "SO WHAT?"</a:t>
+            </a:r>
+          </a:p>
+          <a:p>
+            <a:r>
+              <a:t>Opinion models treat media as a push, but everyone guesses how big it is. I built a way to measure a candidate for that push from the content itself. It picks up real, repeatable differences between kinds of articles, though it is tangled with where they came from, so I don't claim it detects manipulation. But even without knowing the exact strength, the measured spread gives a floor: media would need a coupling of at least 4.29 to flip a strongly connected group. That turns a guessed number into a testable one.</a:t>
             </a:r>
           </a:p>
         </p:txBody>
@@ -1109,6 +1126,12 @@
           <a:lstStyle/>
           <a:p>
             <a:r>
+              <a:t>KEY POINT: The brain model matches real brains weakly but positively: a usable, not perfect, instrument.</a:t>
+            </a:r>
+          </a:p>
+          <a:p/>
+          <a:p>
+            <a:r>
               <a:t>SCRIPT (about 1 min)</a:t>
             </a:r>
           </a:p>
@@ -1236,12 +1259,18 @@
           <a:lstStyle/>
           <a:p>
             <a:r>
+              <a:t>KEY POINT: Even without measuring alpha, the measured spread sets a floor: alpha at least 4.29 at beta J = 2. The source confound does not break it.</a:t>
+            </a:r>
+          </a:p>
+          <a:p/>
+          <a:p>
+            <a:r>
               <a:t>SCRIPT (about 1.5 min)</a:t>
             </a:r>
           </a:p>
           <a:p>
             <a:r>
-              <a:t>The physics result. We connect our score to the model by saying the external field, the media push, equals a coupling constant alpha times our observable X, the score. We could not measure alpha, so we asked how big it must be to flip a majority. The model gives the critical field, h c: the smallest outside push that flips the group's average opinion, like the field needed to flip a magnet. It grows with the reduced coupling, beta J, which is how strongly people copy each other. Above one, a group settles on a majority by itself, like a magnet below its Curie temperature. Dividing the critical field by the spread of our scores, delta X of 0.124, gives the curve. When beta J is 2, a strongly connected group, alpha must be at least 4.29. It is a bar any future claim must clear, not a claim that media flips opinion.</a:t>
+              <a:t>We link our score to the model: the external field equals a coupling constant, alpha, times our score X. We couldn't measure alpha, so we asked how big it must be to flip a majority. The critical field, h c, is the smallest push that does that, and it grows with the reduced coupling, beta J, how strongly people copy each other. Divide it by the spread of our scores, 0.124, and you get this curve. At beta J of 2, alpha must be at least 4.29. A bar to clear, not a claim that media flips opinion.</a:t>
             </a:r>
           </a:p>
           <a:p/>
@@ -1299,6 +1328,17 @@
           <a:p>
             <a:r>
               <a:t>- Lower bound: a minimum value; the result says alpha can't be smaller than this.</a:t>
+            </a:r>
+          </a:p>
+          <a:p/>
+          <a:p>
+            <a:r>
+              <a:t>IF ASKED "SO WHAT?"</a:t>
+            </a:r>
+          </a:p>
+          <a:p>
+            <a:r>
+              <a:t>Opinion models treat media as a push, but everyone guesses how big it is. I built a way to measure a candidate for that push from the content itself. It picks up real, repeatable differences between kinds of articles, though it is tangled with where they came from, so I don't claim it detects manipulation. But even without knowing the exact strength, the measured spread gives a floor: media would need a coupling of at least 4.29 to flip a strongly connected group. That turns a guessed number into a testable one.</a:t>
             </a:r>
           </a:p>
           <a:p/>
@@ -1395,6 +1435,12 @@
           <a:lstStyle/>
           <a:p>
             <a:r>
+              <a:t>KEY POINT: Technically possible, not yet valid for children: the model learned from adult brains.</a:t>
+            </a:r>
+          </a:p>
+          <a:p/>
+          <a:p>
+            <a:r>
               <a:t>SCRIPT (about 1 min)</a:t>
             </a:r>
           </a:p>
@@ -1535,6 +1581,12 @@
           <a:lstStyle/>
           <a:p>
             <a:r>
+              <a:t>KEY POINT: Every limit is stated openly and points to a specific next study.</a:t>
+            </a:r>
+          </a:p>
+          <a:p/>
+          <a:p>
+            <a:r>
               <a:t>SCRIPT (about 0.5 min)</a:t>
             </a:r>
           </a:p>
@@ -1637,6 +1689,12 @@
           <a:lstStyle/>
           <a:p>
             <a:r>
+              <a:t>KEY POINT: The work opens three paths: publishing, extensions (Kenya, video, children), and postgraduate research.</a:t>
+            </a:r>
+          </a:p>
+          <a:p/>
+          <a:p>
+            <a:r>
               <a:t>SCRIPT (about 1 min)</a:t>
             </a:r>
           </a:p>
@@ -1776,6 +1834,12 @@
           <a:lstStyle/>
           <a:p>
             <a:r>
+              <a:t>KEY POINT: Three papers follow. Today I need corrections, the signature and library clearance.</a:t>
+            </a:r>
+          </a:p>
+          <a:p/>
+          <a:p>
+            <a:r>
               <a:t>SCRIPT (about 1.5 min)</a:t>
             </a:r>
           </a:p>
@@ -1809,6 +1873,17 @@
           <a:p>
             <a:r>
               <a:t>- Library deposit: submitting the bound thesis to the university library, needed for graduation clearance.</a:t>
+            </a:r>
+          </a:p>
+          <a:p/>
+          <a:p>
+            <a:r>
+              <a:t>IF ASKED "SO WHAT?"</a:t>
+            </a:r>
+          </a:p>
+          <a:p>
+            <a:r>
+              <a:t>Opinion models treat media as a push, but everyone guesses how big it is. I built a way to measure a candidate for that push from the content itself. It picks up real, repeatable differences between kinds of articles, though it is tangled with where they came from, so I don't claim it detects manipulation. But even without knowing the exact strength, the measured spread gives a floor: media would need a coupling of at least 4.29 to flip a strongly connected group. That turns a guessed number into a testable one.</a:t>
             </a:r>
           </a:p>
         </p:txBody>
@@ -1878,12 +1953,18 @@
           <a:lstStyle/>
           <a:p>
             <a:r>
+              <a:t>KEY POINT: In the opinion model, the external field (media's push) is an input nobody measures. That gap is the whole project.</a:t>
+            </a:r>
+          </a:p>
+          <a:p/>
+          <a:p>
+            <a:r>
               <a:t>SCRIPT (about 1 min)</a:t>
             </a:r>
           </a:p>
           <a:p>
             <a:r>
-              <a:t>Physicists model a group forming an opinion with the Ising model, the same maths as tiny magnets lining up. In a magnet each atom's spin points up or down; here each person holds one of two opinions. The equation says the magnetisation equals tanh of the reduced coupling times the magnetisation, plus the external field. The magnetisation, m, is not mass: it is the average direction of all the spins, so here it is the group's average opinion, from minus one, everyone against, to plus one, everyone for. The coupling, J, is how strongly each person is pulled toward the people around them. Beta is the inverse temperature: in a magnet, one over the temperature; here, how firmly people follow that pull instead of acting at random. The external field, h, is in a magnet an outside magnetic field; here it is the push from media, the same on everyone. In every study I read, the external field is chosen by hand. My question: can we measure it from the content itself?</a:t>
+              <a:t>This is the Ising model, the maths of magnets lining up, used here for opinions. Each person is like a spin, pointing for or against. The magnetisation, m, not mass, is the group's average opinion, from minus one to plus one. The coupling, J, is how strongly people copy those around them. Beta, the inverse temperature, is how firmly they follow that pull rather than act at random. The external field, h, is media's push on everyone. Every study picks h by hand. My question: can we measure it from the content itself?</a:t>
             </a:r>
           </a:p>
           <a:p/>
@@ -2005,6 +2086,12 @@
           <a:lstStyle/>
           <a:p>
             <a:r>
+              <a:t>KEY POINT: Testing the tools changed the plan. Every change is documented and approved, not hidden.</a:t>
+            </a:r>
+          </a:p>
+          <a:p/>
+          <a:p>
+            <a:r>
               <a:t>SCRIPT (about 1.5 min)</a:t>
             </a:r>
           </a:p>
@@ -2133,6 +2220,12 @@
           <a:lstStyle/>
           <a:p>
             <a:r>
+              <a:t>KEY POINT: Every value is a prediction from a published brain model, not a scan of anyone, and anyone can check it on the live tool.</a:t>
+            </a:r>
+          </a:p>
+          <a:p/>
+          <a:p>
+            <a:r>
               <a:t>SCRIPT (about 1.5 min)</a:t>
             </a:r>
           </a:p>
@@ -2308,6 +2401,12 @@
           <a:lstStyle/>
           <a:p>
             <a:r>
+              <a:t>KEY POINT: The article set was designed fairly before scanning: equal groups, equal length, big enough to see a small effect.</a:t>
+            </a:r>
+          </a:p>
+          <a:p/>
+          <a:p>
+            <a:r>
               <a:t>SCRIPT (about 1 min)</a:t>
             </a:r>
           </a:p>
@@ -2457,6 +2556,12 @@
           <a:lstStyle/>
           <a:p>
             <a:r>
+              <a:t>KEY POINT: The groups really differ, but group explains only about 11%. Most variation is between individual articles.</a:t>
+            </a:r>
+          </a:p>
+          <a:p/>
+          <a:p>
+            <a:r>
               <a:t>SCRIPT (about 1 min)</a:t>
             </a:r>
           </a:p>
@@ -2574,6 +2679,12 @@
           <a:lstStyle/>
           <a:p>
             <a:r>
+              <a:t>KEY POINT: Fear drives the effect. Outrage stays flat because it lifts emotion and reasoning together, not because it has no effect.</a:t>
+            </a:r>
+          </a:p>
+          <a:p/>
+          <a:p>
+            <a:r>
               <a:t>SCRIPT (about 1 min)</a:t>
             </a:r>
           </a:p>
@@ -2686,6 +2797,12 @@
           <a:lstStyle/>
           <a:p>
             <a:r>
+              <a:t>KEY POINT: The score is reliable for groups, not for single articles.</a:t>
+            </a:r>
+          </a:p>
+          <a:p/>
+          <a:p>
+            <a:r>
               <a:t>SCRIPT (about 1 min)</a:t>
             </a:r>
           </a:p>
@@ -2796,6 +2913,12 @@
         <p:txBody>
           <a:bodyPr/>
           <a:lstStyle/>
+          <a:p>
+            <a:r>
+              <a:t>KEY POINT: The score is tangled with source, so it is a physics measurement, not a manipulation detector.</a:t>
+            </a:r>
+          </a:p>
+          <a:p/>
           <a:p>
             <a:r>
               <a:t>SCRIPT (about 1.5 min)</a:t>

</xml_diff>